<commit_message>
Reconcile presentation claims with current artifacts
</commit_message>
<xml_diff>
--- a/presentation.pptx
+++ b/presentation.pptx
@@ -3213,7 +3213,7 @@
                   <a:srgbClr val="888888"/>
                 </a:solidFill>
               </a:rPr>
-              <a:t>A two-track pipeline for systematic attack and defense evaluation across YOLO model generations</a:t>
+              <a:t>Two complementary tracks for attack analysis and defense-cycle evaluation across YOLO generations</a:t>
             </a:r>
           </a:p>
         </p:txBody>
@@ -3409,7 +3409,7 @@
         <p:spPr>
           <a:xfrm>
             <a:off x="822960" y="2148840"/>
-            <a:ext cx="3291840" cy="2240280"/>
+            <a:ext cx="3291840" cy="2468880"/>
           </a:xfrm>
           <a:prstGeom prst="rect">
             <a:avLst/>
@@ -3486,27 +3486,27 @@
         <p:spPr>
           <a:xfrm>
             <a:off x="1005840" y="2651760"/>
-            <a:ext cx="3017520" cy="1417320"/>
-          </a:xfrm>
-          <a:prstGeom prst="rect">
-            <a:avLst/>
-          </a:prstGeom>
-          <a:noFill/>
-        </p:spPr>
-        <p:txBody>
-          <a:bodyPr wrap="square">
-            <a:spAutoFit/>
-          </a:bodyPr>
-          <a:lstStyle/>
-          <a:p>
-            <a:pPr algn="l"/>
-            <a:r>
-              <a:rPr sz="1300" b="0" i="0">
+            <a:ext cx="3017520" cy="1737360"/>
+          </a:xfrm>
+          <a:prstGeom prst="rect">
+            <a:avLst/>
+          </a:prstGeom>
+          <a:noFill/>
+        </p:spPr>
+        <p:txBody>
+          <a:bodyPr wrap="square">
+            <a:spAutoFit/>
+          </a:bodyPr>
+          <a:lstStyle/>
+          <a:p>
+            <a:pPr algn="l"/>
+            <a:r>
+              <a:rPr sz="1200" b="0" i="0">
                 <a:solidFill>
                   <a:srgbClr val="CCCCCC"/>
                 </a:solidFill>
               </a:rPr>
-              <a:t>A reproducible two-track pipeline producing schema-enforced results across 3 YOLO generations, 3 attack types, 4 defense types, and 22 automated cycles.</a:t>
+              <a:t>Two complementary repos, not one merged pipeline: Adversarial_Patch reports cross-generation patch training and transfer on YOLOv8n, YOLO11n, and YOLO26n; YOLO-Bad-Triangle reports 22 recorded defense-cycle artifacts, with current canonical trends taken from the post-switch series.</a:t>
             </a:r>
           </a:p>
         </p:txBody>
@@ -3520,7 +3520,7 @@
         <p:spPr>
           <a:xfrm>
             <a:off x="4480560" y="2148840"/>
-            <a:ext cx="3291840" cy="2240280"/>
+            <a:ext cx="3291840" cy="2468880"/>
           </a:xfrm>
           <a:prstGeom prst="rect">
             <a:avLst/>
@@ -3597,22 +3597,22 @@
         <p:spPr>
           <a:xfrm>
             <a:off x="4663440" y="2651760"/>
-            <a:ext cx="3017520" cy="1417320"/>
-          </a:xfrm>
-          <a:prstGeom prst="rect">
-            <a:avLst/>
-          </a:prstGeom>
-          <a:noFill/>
-        </p:spPr>
-        <p:txBody>
-          <a:bodyPr wrap="square">
-            <a:spAutoFit/>
-          </a:bodyPr>
-          <a:lstStyle/>
-          <a:p>
-            <a:pPr algn="l"/>
-            <a:r>
-              <a:rPr sz="1300" b="0" i="0">
+            <a:ext cx="3017520" cy="1737360"/>
+          </a:xfrm>
+          <a:prstGeom prst="rect">
+            <a:avLst/>
+          </a:prstGeom>
+          <a:noFill/>
+        </p:spPr>
+        <p:txBody>
+          <a:bodyPr wrap="square">
+            <a:spAutoFit/>
+          </a:bodyPr>
+          <a:lstStyle/>
+          <a:p>
+            <a:pPr algn="l"/>
+            <a:r>
+              <a:rPr sz="1200" b="0" i="0">
                 <a:solidFill>
                   <a:srgbClr val="CCCCCC"/>
                 </a:solidFill>
@@ -3631,7 +3631,7 @@
         <p:spPr>
           <a:xfrm>
             <a:off x="8138160" y="2148840"/>
-            <a:ext cx="3291840" cy="2240280"/>
+            <a:ext cx="3291840" cy="2468880"/>
           </a:xfrm>
           <a:prstGeom prst="rect">
             <a:avLst/>
@@ -3708,22 +3708,22 @@
         <p:spPr>
           <a:xfrm>
             <a:off x="8321040" y="2651760"/>
-            <a:ext cx="3017520" cy="1417320"/>
-          </a:xfrm>
-          <a:prstGeom prst="rect">
-            <a:avLst/>
-          </a:prstGeom>
-          <a:noFill/>
-        </p:spPr>
-        <p:txBody>
-          <a:bodyPr wrap="square">
-            <a:spAutoFit/>
-          </a:bodyPr>
-          <a:lstStyle/>
-          <a:p>
-            <a:pPr algn="l"/>
-            <a:r>
-              <a:rPr sz="1300" b="0" i="0">
+            <a:ext cx="3017520" cy="1737360"/>
+          </a:xfrm>
+          <a:prstGeom prst="rect">
+            <a:avLst/>
+          </a:prstGeom>
+          <a:noFill/>
+        </p:spPr>
+        <p:txBody>
+          <a:bodyPr wrap="square">
+            <a:spAutoFit/>
+          </a:bodyPr>
+          <a:lstStyle/>
+          <a:p>
+            <a:pPr algn="l"/>
+            <a:r>
+              <a:rPr sz="1200" b="0" i="0">
                 <a:solidFill>
                   <a:srgbClr val="CCCCCC"/>
                 </a:solidFill>
@@ -3785,27 +3785,28 @@
         <p:spPr>
           <a:xfrm>
             <a:off x="822960" y="5440680"/>
-            <a:ext cx="10515600" cy="365760"/>
-          </a:xfrm>
-          <a:prstGeom prst="rect">
-            <a:avLst/>
-          </a:prstGeom>
-          <a:noFill/>
-        </p:spPr>
-        <p:txBody>
-          <a:bodyPr wrap="square">
-            <a:spAutoFit/>
-          </a:bodyPr>
-          <a:lstStyle/>
-          <a:p>
-            <a:pPr algn="l"/>
-            <a:r>
-              <a:rPr sz="1200" b="0" i="0">
+            <a:ext cx="10515600" cy="548640"/>
+          </a:xfrm>
+          <a:prstGeom prst="rect">
+            <a:avLst/>
+          </a:prstGeom>
+          <a:noFill/>
+        </p:spPr>
+        <p:txBody>
+          <a:bodyPr wrap="square">
+            <a:spAutoFit/>
+          </a:bodyPr>
+          <a:lstStyle/>
+          <a:p>
+            <a:pPr algn="l"/>
+            <a:r>
+              <a:rPr sz="1100" b="0" i="0">
                 <a:solidFill>
                   <a:srgbClr val="60B8FF"/>
                 </a:solidFill>
               </a:rPr>
-              <a:t>Training script | Colab notebook | Live demo | All results -&gt; github.com/Cmaddock99/Patch_Yolo</a:t>
+              <a:t>Attack repo -&gt; github.com/Cmaddock99/Patch_Yolo
+Defense repo -&gt; github.com/Cmaddock99/YOLO-Bad-Triangle</a:t>
             </a:r>
           </a:p>
         </p:txBody>
@@ -3899,7 +3900,7 @@
                   <a:srgbClr val="E8E8F0"/>
                 </a:solidFill>
               </a:rPr>
-              <a:t>Two-Track</a:t>
+              <a:t>Two Complementary</a:t>
             </a:r>
           </a:p>
           <a:p>
@@ -3910,7 +3911,7 @@
                   <a:srgbClr val="60B8FF"/>
                 </a:solidFill>
               </a:rPr>
-              <a:t>Pipeline</a:t>
+              <a:t>Tracks</a:t>
             </a:r>
           </a:p>
         </p:txBody>
@@ -4086,7 +4087,7 @@
                   <a:srgbClr val="CCCCCC"/>
                 </a:solidFill>
               </a:rPr>
-              <a:t>- Cross-architecture transfer evaluation</a:t>
+              <a:t>- Cross-model transfer evaluation across YOLO generations</a:t>
             </a:r>
           </a:p>
           <a:p>
@@ -4273,7 +4274,7 @@
                   <a:srgbClr val="CCCCCC"/>
                 </a:solidFill>
               </a:rPr>
-              <a:t>- 22 automated hyperparameter-optimization cycles</a:t>
+              <a:t>- 22 recorded automated cycles in the defense repo</a:t>
             </a:r>
           </a:p>
           <a:p>
@@ -4284,7 +4285,7 @@
                   <a:srgbClr val="CCCCCC"/>
                 </a:solidFill>
               </a:rPr>
-              <a:t>- Adversarial finetuning with a clean A/B deployment gate</a:t>
+              <a:t>- DPC-UNet checkpoint finetuning with clean A/B deployment gate</a:t>
             </a:r>
           </a:p>
           <a:p>
@@ -4320,27 +4321,27 @@
         <p:spPr>
           <a:xfrm>
             <a:off x="822960" y="4983480"/>
-            <a:ext cx="10424160" cy="548640"/>
-          </a:xfrm>
-          <a:prstGeom prst="rect">
-            <a:avLst/>
-          </a:prstGeom>
-          <a:noFill/>
-        </p:spPr>
-        <p:txBody>
-          <a:bodyPr wrap="square">
-            <a:spAutoFit/>
-          </a:bodyPr>
-          <a:lstStyle/>
-          <a:p>
-            <a:pPr algn="l"/>
-            <a:r>
-              <a:rPr sz="1300" b="0" i="0">
+            <a:ext cx="10424160" cy="731520"/>
+          </a:xfrm>
+          <a:prstGeom prst="rect">
+            <a:avLst/>
+          </a:prstGeom>
+          <a:noFill/>
+        </p:spPr>
+        <p:txBody>
+          <a:bodyPr wrap="square">
+            <a:spAutoFit/>
+          </a:bodyPr>
+          <a:lstStyle/>
+          <a:p>
+            <a:pPr algn="l"/>
+            <a:r>
+              <a:rPr sz="1200" b="0" i="0">
                 <a:solidFill>
                   <a:srgbClr val="888888"/>
                 </a:solidFill>
               </a:rPr>
-              <a:t>Both tracks share a common image set and produce structured artifacts. Findings from each cycle inform the next.</a:t>
+              <a:t>These are complementary sibling repos, not one shared-image runtime loop: the attack track uses a 48-image common manifest, while the defense track runs automated cycles on a COCO subset and writes its own reports.</a:t>
             </a:r>
           </a:p>
         </p:txBody>
@@ -5470,7 +5471,7 @@
                   <a:srgbClr val="FFE066"/>
                 </a:solidFill>
               </a:rPr>
-              <a:t>36.4%</a:t>
+              <a:t>33.3%</a:t>
             </a:r>
           </a:p>
         </p:txBody>
@@ -5504,7 +5505,7 @@
                   <a:srgbClr val="FF6060"/>
                 </a:solidFill>
               </a:rPr>
-              <a:t>11.6%</a:t>
+              <a:t>14.0%</a:t>
             </a:r>
           </a:p>
         </p:txBody>
@@ -6098,28 +6099,28 @@
         <p:spPr>
           <a:xfrm>
             <a:off x="7635240" y="2578608"/>
-            <a:ext cx="3520440" cy="822960"/>
-          </a:xfrm>
-          <a:prstGeom prst="rect">
-            <a:avLst/>
-          </a:prstGeom>
-          <a:noFill/>
-        </p:spPr>
-        <p:txBody>
-          <a:bodyPr wrap="square">
-            <a:spAutoFit/>
-          </a:bodyPr>
-          <a:lstStyle/>
-          <a:p>
-            <a:pPr algn="l"/>
-            <a:r>
-              <a:rPr sz="1200" b="0" i="0">
+            <a:ext cx="3520440" cy="914400"/>
+          </a:xfrm>
+          <a:prstGeom prst="rect">
+            <a:avLst/>
+          </a:prstGeom>
+          <a:noFill/>
+        </p:spPr>
+        <p:txBody>
+          <a:bodyPr wrap="square">
+            <a:spAutoFit/>
+          </a:bodyPr>
+          <a:lstStyle/>
+          <a:p>
+            <a:pPr algn="l"/>
+            <a:r>
+              <a:rPr sz="1100" b="0" i="0">
                 <a:solidFill>
                   <a:srgbClr val="CCCCCC"/>
                 </a:solidFill>
               </a:rPr>
-              <a:t>v11n -&gt; v8n = 50%  &gt;  v8n -&gt; v11n = 36.4%
-Newer-generation patches reach backward better than older patches reach forward.</a:t>
+              <a:t>v11n -&gt; v8n = 50.0%  &gt;  v8n -&gt; v11n = 33.3%
+The asymmetry remains in the current v2 artifacts: newer-generation patches still reach backward better than older patches reach forward.</a:t>
             </a:r>
           </a:p>
         </p:txBody>
@@ -6133,7 +6134,7 @@
         <p:spPr>
           <a:xfrm>
             <a:off x="7452360" y="3657600"/>
-            <a:ext cx="3886200" cy="1828800"/>
+            <a:ext cx="3886200" cy="1874519"/>
           </a:xfrm>
           <a:prstGeom prst="rect">
             <a:avLst/>
@@ -6210,29 +6211,28 @@
         <p:spPr>
           <a:xfrm>
             <a:off x="7635240" y="4087368"/>
-            <a:ext cx="3520440" cy="1280160"/>
-          </a:xfrm>
-          <a:prstGeom prst="rect">
-            <a:avLst/>
-          </a:prstGeom>
-          <a:noFill/>
-        </p:spPr>
-        <p:txBody>
-          <a:bodyPr wrap="square">
-            <a:spAutoFit/>
-          </a:bodyPr>
-          <a:lstStyle/>
-          <a:p>
-            <a:pPr algn="l"/>
-            <a:r>
-              <a:rPr sz="1200" b="0" i="0">
+            <a:ext cx="3520440" cy="1325880"/>
+          </a:xfrm>
+          <a:prstGeom prst="rect">
+            <a:avLst/>
+          </a:prstGeom>
+          <a:noFill/>
+        </p:spPr>
+        <p:txBody>
+          <a:bodyPr wrap="square">
+            <a:spAutoFit/>
+          </a:bodyPr>
+          <a:lstStyle/>
+          <a:p>
+            <a:pPr algn="l"/>
+            <a:r>
+              <a:rPr sz="1100" b="0" i="0">
                 <a:solidFill>
                   <a:srgbClr val="CCCCCC"/>
                 </a:solidFill>
               </a:rPr>
-              <a:t>v26n is the hardest target in this matrix - nothing exceeds 18.6% against it.
-Its own patch still transfers out at 45% and 24.2%.
-In this setup, resistance as a target did not stop it from producing transferable adversarial structure.</a:t>
+              <a:t>v26n remains the hardest target in this study. Nothing in the direct matrix exceeds 16.3% against it, and even the best joint patch only reaches 18.6%.
+Yet the v26n patch still transfers out at 45.0% and 24.2%.</a:t>
             </a:r>
           </a:p>
         </p:txBody>
@@ -6594,27 +6594,27 @@
         <p:spPr>
           <a:xfrm>
             <a:off x="1005840" y="5321808"/>
-            <a:ext cx="4983480" cy="411480"/>
-          </a:xfrm>
-          <a:prstGeom prst="rect">
-            <a:avLst/>
-          </a:prstGeom>
-          <a:noFill/>
-        </p:spPr>
-        <p:txBody>
-          <a:bodyPr wrap="square">
-            <a:spAutoFit/>
-          </a:bodyPr>
-          <a:lstStyle/>
-          <a:p>
-            <a:pPr algn="l"/>
-            <a:r>
-              <a:rPr sz="1100" b="0" i="0">
+            <a:ext cx="4983480" cy="548640"/>
+          </a:xfrm>
+          <a:prstGeom prst="rect">
+            <a:avLst/>
+          </a:prstGeom>
+          <a:noFill/>
+        </p:spPr>
+        <p:txBody>
+          <a:bodyPr wrap="square">
+            <a:spAutoFit/>
+          </a:bodyPr>
+          <a:lstStyle/>
+          <a:p>
+            <a:pPr algn="l"/>
+            <a:r>
+              <a:rPr sz="1000" b="0" i="0">
                 <a:solidFill>
                   <a:srgbClr val="CCCCCC"/>
                 </a:solidFill>
               </a:rPr>
-              <a:t>High variance across seeds. No consistent reduction at 95% or 90% retention. Occasional reductions at 85% retention were unreliable and costly to clean detection rate.</a:t>
+              <a:t>High variance across seeds. At 95% and 90% retention there is no reliable benefit. Some 85% retention and isolated 90% retention seeds reduce suppression, but the effect is unstable and often trades off against clean detections.</a:t>
             </a:r>
           </a:p>
         </p:txBody>
@@ -7693,27 +7693,27 @@
         <p:spPr>
           <a:xfrm>
             <a:off x="822960" y="1828800"/>
-            <a:ext cx="5303520" cy="731520"/>
-          </a:xfrm>
-          <a:prstGeom prst="rect">
-            <a:avLst/>
-          </a:prstGeom>
-          <a:noFill/>
-        </p:spPr>
-        <p:txBody>
-          <a:bodyPr wrap="square">
-            <a:spAutoFit/>
-          </a:bodyPr>
-          <a:lstStyle/>
-          <a:p>
-            <a:pPr algn="l"/>
-            <a:r>
-              <a:rPr sz="1300" b="0" i="0">
+            <a:ext cx="5303520" cy="1051560"/>
+          </a:xfrm>
+          <a:prstGeom prst="rect">
+            <a:avLst/>
+          </a:prstGeom>
+          <a:noFill/>
+        </p:spPr>
+        <p:txBody>
+          <a:bodyPr wrap="square">
+            <a:spAutoFit/>
+          </a:bodyPr>
+          <a:lstStyle/>
+          <a:p>
+            <a:pPr algn="l"/>
+            <a:r>
+              <a:rPr sz="1200" b="0" i="0">
                 <a:solidFill>
                   <a:srgbClr val="CCCCCC"/>
                 </a:solidFill>
               </a:rPr>
-              <a:t>YOLO-Bad-Triangle framework: 22 automated cycles of optimized attacks versus optimized defenses. Attacks: square, DeepFool, dispersion reduction. Defenses: JPEG, median filter, bit-depth reduction, c_dog.</a:t>
+              <a:t>This slide uses the latest canonical cycle from YOLO-Bad-Triangle. The repo records 22 cycles overall, but this snapshot is cycle 22 from the current attack_then_defense series. Latest validated attacks: DeepFool, dispersion reduction, and square. Active defenses: JPEG, median filter, bit-depth reduction, and c_dog.</a:t>
             </a:r>
           </a:p>
         </p:txBody>
@@ -7726,7 +7726,7 @@
         </p:nvSpPr>
         <p:spPr>
           <a:xfrm>
-            <a:off x="822960" y="2651760"/>
+            <a:off x="822960" y="2834640"/>
             <a:ext cx="5303520" cy="1554480"/>
           </a:xfrm>
           <a:prstGeom prst="rect">
@@ -7769,7 +7769,7 @@
         </p:nvSpPr>
         <p:spPr>
           <a:xfrm>
-            <a:off x="1005840" y="2926080"/>
+            <a:off x="1005840" y="3090672"/>
             <a:ext cx="4937760" cy="914400"/>
           </a:xfrm>
           <a:prstGeom prst="rect">
@@ -7807,23 +7807,23 @@
           <a:p>
             <a:pPr algn="l"/>
             <a:r>
-              <a:rPr sz="1200" b="0" i="0">
+              <a:rPr sz="1100" b="0" i="0">
                 <a:solidFill>
                   <a:srgbClr val="FF6060"/>
                 </a:solidFill>
               </a:rPr>
-              <a:t>Best attack   dispersion_reduction       0.238      -60%</a:t>
-            </a:r>
-          </a:p>
-          <a:p>
-            <a:pPr algn="l"/>
-            <a:r>
-              <a:rPr sz="1200" b="0" i="0">
+              <a:t>Worst latest-cycle attack   dispersion_reduction    0.238   -60%</a:t>
+            </a:r>
+          </a:p>
+          <a:p>
+            <a:pPr algn="l"/>
+            <a:r>
+              <a:rPr sz="1100" b="0" i="0">
                 <a:solidFill>
                   <a:srgbClr val="FFE066"/>
                 </a:solidFill>
               </a:rPr>
-              <a:t>Best defense  square + c_dog             0.394      -34%</a:t>
+              <a:t>Best latest-cycle defended config  square + c_dog  0.394   -34%</a:t>
             </a:r>
           </a:p>
         </p:txBody>
@@ -7837,7 +7837,7 @@
         <p:spPr>
           <a:xfrm>
             <a:off x="6537960" y="1828800"/>
-            <a:ext cx="4800600" cy="1920240"/>
+            <a:ext cx="4800600" cy="2148840"/>
           </a:xfrm>
           <a:prstGeom prst="rect">
             <a:avLst/>
@@ -7914,27 +7914,27 @@
         <p:spPr>
           <a:xfrm>
             <a:off x="6720840" y="2267712"/>
-            <a:ext cx="4480560" cy="731520"/>
-          </a:xfrm>
-          <a:prstGeom prst="rect">
-            <a:avLst/>
-          </a:prstGeom>
-          <a:noFill/>
-        </p:spPr>
-        <p:txBody>
-          <a:bodyPr wrap="square">
-            <a:spAutoFit/>
-          </a:bodyPr>
-          <a:lstStyle/>
-          <a:p>
-            <a:pPr algn="l"/>
-            <a:r>
-              <a:rPr sz="1200" b="0" i="0">
+            <a:ext cx="4480560" cy="914400"/>
+          </a:xfrm>
+          <a:prstGeom prst="rect">
+            <a:avLst/>
+          </a:prstGeom>
+          <a:noFill/>
+        </p:spPr>
+        <p:txBody>
+          <a:bodyPr wrap="square">
+            <a:spAutoFit/>
+          </a:bodyPr>
+          <a:lstStyle/>
+          <a:p>
+            <a:pPr algn="l"/>
+            <a:r>
+              <a:rPr sz="1100" b="0" i="0">
                 <a:solidFill>
                   <a:srgbClr val="CCCCCC"/>
                 </a:solidFill>
               </a:rPr>
-              <a:t>DPC-UNet detector finetuned on adversarial examples (square x5 oversample + DeepFool + blur pairs). Deployed only after the clean A/B gate.</a:t>
+              <a:t>DPC-UNet denoiser checkpoint finetuned on adversarial image pairs (square x5 oversample + DeepFool + blur + square pairs). Candidate deployed only after clean A/B comparison against the current c_dog checkpoint.</a:t>
             </a:r>
           </a:p>
         </p:txBody>
@@ -7947,34 +7947,34 @@
         </p:nvSpPr>
         <p:spPr>
           <a:xfrm>
-            <a:off x="6720840" y="3063240"/>
-            <a:ext cx="4480560" cy="502920"/>
-          </a:xfrm>
-          <a:prstGeom prst="rect">
-            <a:avLst/>
-          </a:prstGeom>
-          <a:noFill/>
-        </p:spPr>
-        <p:txBody>
-          <a:bodyPr wrap="square">
-            <a:spAutoFit/>
-          </a:bodyPr>
-          <a:lstStyle/>
-          <a:p>
-            <a:pPr algn="l"/>
-            <a:r>
-              <a:rPr sz="1200" b="0" i="0">
+            <a:off x="6720840" y="3200400"/>
+            <a:ext cx="4480560" cy="594360"/>
+          </a:xfrm>
+          <a:prstGeom prst="rect">
+            <a:avLst/>
+          </a:prstGeom>
+          <a:noFill/>
+        </p:spPr>
+        <p:txBody>
+          <a:bodyPr wrap="square">
+            <a:spAutoFit/>
+          </a:bodyPr>
+          <a:lstStyle/>
+          <a:p>
+            <a:pPr algn="l"/>
+            <a:r>
+              <a:rPr sz="1100" b="0" i="0">
                 <a:solidFill>
                   <a:srgbClr val="CCCCCC"/>
                 </a:solidFill>
               </a:rPr>
-              <a:t>- Clean performance: +0.003 mAP50 - no regression</a:t>
-            </a:r>
-          </a:p>
-          <a:p>
-            <a:pPr algn="l"/>
-            <a:r>
-              <a:rPr sz="1200" b="0" i="0">
+              <a:t>- Clean performance: +0.0025 mAP50 versus previous checkpoint - no regression</a:t>
+            </a:r>
+          </a:p>
+          <a:p>
+            <a:pPr algn="l"/>
+            <a:r>
+              <a:rPr sz="1100" b="0" i="0">
                 <a:solidFill>
                   <a:srgbClr val="CCCCCC"/>
                 </a:solidFill>
@@ -7992,8 +7992,8 @@
         </p:nvSpPr>
         <p:spPr>
           <a:xfrm>
-            <a:off x="6537960" y="4069080"/>
-            <a:ext cx="4800600" cy="1417320"/>
+            <a:off x="6537960" y="4160520"/>
+            <a:ext cx="4800600" cy="1325880"/>
           </a:xfrm>
           <a:prstGeom prst="rect">
             <a:avLst/>
@@ -8069,28 +8069,28 @@
         </p:nvSpPr>
         <p:spPr>
           <a:xfrm>
-            <a:off x="6720840" y="4507992"/>
-            <a:ext cx="4480560" cy="749808"/>
-          </a:xfrm>
-          <a:prstGeom prst="rect">
-            <a:avLst/>
-          </a:prstGeom>
-          <a:noFill/>
-        </p:spPr>
-        <p:txBody>
-          <a:bodyPr wrap="square">
-            <a:spAutoFit/>
-          </a:bodyPr>
-          <a:lstStyle/>
-          <a:p>
-            <a:pPr algn="l"/>
-            <a:r>
-              <a:rPr sz="1200" b="0" i="0">
+            <a:off x="6720840" y="4480560"/>
+            <a:ext cx="4480560" cy="822960"/>
+          </a:xfrm>
+          <a:prstGeom prst="rect">
+            <a:avLst/>
+          </a:prstGeom>
+          <a:noFill/>
+        </p:spPr>
+        <p:txBody>
+          <a:bodyPr wrap="square">
+            <a:spAutoFit/>
+          </a:bodyPr>
+          <a:lstStyle/>
+          <a:p>
+            <a:pPr algn="l"/>
+            <a:r>
+              <a:rPr sz="1100" b="0" i="0">
                 <a:solidFill>
                   <a:srgbClr val="CCCCCC"/>
                 </a:solidFill>
               </a:rPr>
-              <a:t>Defenses partially recover attacked performance - from -60% to -34%. Finetuning is clean-safe but has not moved the needle on robustness yet. The arms race is still live.</a:t>
+              <a:t>No universal defense has emerged. In the current canonical series, c_dog is strongest on square, while median preprocessing is stronger on deepfool. Finetuning is clean-safe but has not yet produced a measurable robustness gain.</a:t>
             </a:r>
           </a:p>
         </p:txBody>
@@ -8272,7 +8272,7 @@
                   <a:srgbClr val="60B8FF"/>
                 </a:solidFill>
               </a:rPr>
-              <a:t>22-CYCLE AUTOMATION PIPELINE</a:t>
+              <a:t>4-PHASE AUTOMATION PIPELINE</a:t>
             </a:r>
           </a:p>
         </p:txBody>
@@ -8286,49 +8286,60 @@
         <p:spPr>
           <a:xfrm>
             <a:off x="1005840" y="2331720"/>
-            <a:ext cx="4937760" cy="1645920"/>
-          </a:xfrm>
-          <a:prstGeom prst="rect">
-            <a:avLst/>
-          </a:prstGeom>
-          <a:noFill/>
-        </p:spPr>
-        <p:txBody>
-          <a:bodyPr wrap="square">
-            <a:spAutoFit/>
-          </a:bodyPr>
-          <a:lstStyle/>
-          <a:p>
-            <a:pPr algn="l"/>
-            <a:r>
-              <a:rPr sz="1200" b="0" i="0">
+            <a:ext cx="4937760" cy="1874519"/>
+          </a:xfrm>
+          <a:prstGeom prst="rect">
+            <a:avLst/>
+          </a:prstGeom>
+          <a:noFill/>
+        </p:spPr>
+        <p:txBody>
+          <a:bodyPr wrap="square">
+            <a:spAutoFit/>
+          </a:bodyPr>
+          <a:lstStyle/>
+          <a:p>
+            <a:pPr algn="l"/>
+            <a:r>
+              <a:rPr sz="1100" b="0" i="0">
                 <a:solidFill>
                   <a:srgbClr val="CCCCCC"/>
                 </a:solidFill>
               </a:rPr>
-              <a:t>- Phase 1 - Attack: optimize patch hyperparameters against the current model; record mAP50 drop</a:t>
-            </a:r>
-          </a:p>
-          <a:p>
-            <a:pPr algn="l"/>
-            <a:r>
-              <a:rPr sz="1200" b="0" i="0">
+              <a:t>- Phase 1 - Characterize: smoke-rank candidate attacks</a:t>
+            </a:r>
+          </a:p>
+          <a:p>
+            <a:pPr algn="l"/>
+            <a:r>
+              <a:rPr sz="1100" b="0" i="0">
                 <a:solidFill>
                   <a:srgbClr val="CCCCCC"/>
                 </a:solidFill>
               </a:rPr>
-              <a:t>- Phase 2 - Defense: tune preprocessing or learned denoiser against the best attack; record mAP50 recovery</a:t>
-            </a:r>
-          </a:p>
-          <a:p>
-            <a:pPr algn="l"/>
-            <a:r>
-              <a:rPr sz="1200" b="0" i="0">
+              <a:t>- Phase 2 - Matrix: smoke-rank candidate defenses against top attacks</a:t>
+            </a:r>
+          </a:p>
+          <a:p>
+            <a:pPr algn="l"/>
+            <a:r>
+              <a:rPr sz="1100" b="0" i="0">
                 <a:solidFill>
                   <a:srgbClr val="CCCCCC"/>
                 </a:solidFill>
               </a:rPr>
-              <a:t>- Phase 3 - Gate + report: deploy only if clean mAP50 stays at or above baseline; emit schema-enforced JSON</a:t>
+              <a:t>- Phase 3 - Tune: coordinate-descent best attack and defense params</a:t>
+            </a:r>
+          </a:p>
+          <a:p>
+            <a:pPr algn="l"/>
+            <a:r>
+              <a:rPr sz="1100" b="0" i="0">
+                <a:solidFill>
+                  <a:srgbClr val="CCCCCC"/>
+                </a:solidFill>
+              </a:rPr>
+              <a:t>- Phase 4 - Validate + report: full-dataset mAP50 validation and artifact/report generation</a:t>
             </a:r>
           </a:p>
         </p:txBody>
@@ -8341,28 +8352,28 @@
         </p:nvSpPr>
         <p:spPr>
           <a:xfrm>
-            <a:off x="1005840" y="4069080"/>
-            <a:ext cx="4937760" cy="411480"/>
-          </a:xfrm>
-          <a:prstGeom prst="rect">
-            <a:avLst/>
-          </a:prstGeom>
-          <a:noFill/>
-        </p:spPr>
-        <p:txBody>
-          <a:bodyPr wrap="square">
-            <a:spAutoFit/>
-          </a:bodyPr>
-          <a:lstStyle/>
-          <a:p>
-            <a:pPr algn="l"/>
-            <a:r>
-              <a:rPr sz="1200" b="0" i="0">
+            <a:off x="1005840" y="4224528"/>
+            <a:ext cx="4937760" cy="502920"/>
+          </a:xfrm>
+          <a:prstGeom prst="rect">
+            <a:avLst/>
+          </a:prstGeom>
+          <a:noFill/>
+        </p:spPr>
+        <p:txBody>
+          <a:bodyPr wrap="square">
+            <a:spAutoFit/>
+          </a:bodyPr>
+          <a:lstStyle/>
+          <a:p>
+            <a:pPr algn="l"/>
+            <a:r>
+              <a:rPr sz="1100" b="0" i="0">
                 <a:solidFill>
                   <a:srgbClr val="CCCCCC"/>
                 </a:solidFill>
               </a:rPr>
-              <a:t>Each cycle produces a provenance-tracked artifact: attack config, defense config, before/after mAP50. No manual bookkeeping.</a:t>
+              <a:t>Checkpoint promotion is a separate clean A/B step for the c_dog denoiser: deploy only if the candidate does not regress versus the current checkpoint.</a:t>
             </a:r>
           </a:p>
         </p:txBody>
@@ -8375,7 +8386,7 @@
         </p:nvSpPr>
         <p:spPr>
           <a:xfrm>
-            <a:off x="1188720" y="4754880"/>
+            <a:off x="1188720" y="4892040"/>
             <a:ext cx="914400" cy="365760"/>
           </a:xfrm>
           <a:prstGeom prst="rect">
@@ -8409,7 +8420,7 @@
         </p:nvSpPr>
         <p:spPr>
           <a:xfrm>
-            <a:off x="2788920" y="4754880"/>
+            <a:off x="2788920" y="4892040"/>
             <a:ext cx="914400" cy="365760"/>
           </a:xfrm>
           <a:prstGeom prst="rect">
@@ -8443,7 +8454,7 @@
         </p:nvSpPr>
         <p:spPr>
           <a:xfrm>
-            <a:off x="4343400" y="4754880"/>
+            <a:off x="4343400" y="4892040"/>
             <a:ext cx="914400" cy="365760"/>
           </a:xfrm>
           <a:prstGeom prst="rect">
@@ -8464,7 +8475,7 @@
                   <a:srgbClr val="FFE066"/>
                 </a:solidFill>
               </a:rPr>
-              <a:t>3</a:t>
+              <a:t>5</a:t>
             </a:r>
           </a:p>
         </p:txBody>
@@ -8477,8 +8488,8 @@
         </p:nvSpPr>
         <p:spPr>
           <a:xfrm>
-            <a:off x="1143000" y="5102352"/>
-            <a:ext cx="1005840" cy="182880"/>
+            <a:off x="1005840" y="5239512"/>
+            <a:ext cx="1280160" cy="182880"/>
           </a:xfrm>
           <a:prstGeom prst="rect">
             <a:avLst/>
@@ -8498,7 +8509,7 @@
                   <a:srgbClr val="888888"/>
                 </a:solidFill>
               </a:rPr>
-              <a:t>cycles run</a:t>
+              <a:t>recorded cycles</a:t>
             </a:r>
           </a:p>
         </p:txBody>
@@ -8511,8 +8522,8 @@
         </p:nvSpPr>
         <p:spPr>
           <a:xfrm>
-            <a:off x="2606040" y="5102352"/>
-            <a:ext cx="1280160" cy="182880"/>
+            <a:off x="2468880" y="5239512"/>
+            <a:ext cx="1554480" cy="182880"/>
           </a:xfrm>
           <a:prstGeom prst="rect">
             <a:avLst/>
@@ -8532,7 +8543,7 @@
                   <a:srgbClr val="888888"/>
                 </a:solidFill>
               </a:rPr>
-              <a:t>defense types</a:t>
+              <a:t>active defenses</a:t>
             </a:r>
           </a:p>
         </p:txBody>
@@ -8545,8 +8556,8 @@
         </p:nvSpPr>
         <p:spPr>
           <a:xfrm>
-            <a:off x="4206240" y="5102352"/>
-            <a:ext cx="1188720" cy="182880"/>
+            <a:off x="3749040" y="5239512"/>
+            <a:ext cx="2103120" cy="182880"/>
           </a:xfrm>
           <a:prstGeom prst="rect">
             <a:avLst/>
@@ -8561,12 +8572,12 @@
           <a:p>
             <a:pPr algn="ctr"/>
             <a:r>
-              <a:rPr sz="900" b="0" i="0">
+              <a:rPr sz="800" b="0" i="0">
                 <a:solidFill>
                   <a:srgbClr val="888888"/>
                 </a:solidFill>
               </a:rPr>
-              <a:t>attack types</a:t>
+              <a:t>canonical post-switch cycles</a:t>
             </a:r>
           </a:p>
         </p:txBody>
@@ -8580,7 +8591,7 @@
         <p:spPr>
           <a:xfrm>
             <a:off x="6537960" y="1828800"/>
-            <a:ext cx="4800600" cy="1645920"/>
+            <a:ext cx="4800600" cy="1783080"/>
           </a:xfrm>
           <a:prstGeom prst="rect">
             <a:avLst/>
@@ -8643,7 +8654,7 @@
                   <a:srgbClr val="60B8FF"/>
                 </a:solidFill>
               </a:rPr>
-              <a:t>c_dog - BEST DEFENSE</a:t>
+              <a:t>c_dog - STRONGEST SQUARE DEFENSE IN CYCLE 22</a:t>
             </a:r>
           </a:p>
         </p:txBody>
@@ -8657,27 +8668,27 @@
         <p:spPr>
           <a:xfrm>
             <a:off x="6720840" y="2267712"/>
-            <a:ext cx="4480560" cy="868680"/>
-          </a:xfrm>
-          <a:prstGeom prst="rect">
-            <a:avLst/>
-          </a:prstGeom>
-          <a:noFill/>
-        </p:spPr>
-        <p:txBody>
-          <a:bodyPr wrap="square">
-            <a:spAutoFit/>
-          </a:bodyPr>
-          <a:lstStyle/>
-          <a:p>
-            <a:pPr algn="l"/>
-            <a:r>
-              <a:rPr sz="1200" b="0" i="0">
+            <a:ext cx="4480560" cy="960120"/>
+          </a:xfrm>
+          <a:prstGeom prst="rect">
+            <a:avLst/>
+          </a:prstGeom>
+          <a:noFill/>
+        </p:spPr>
+        <p:txBody>
+          <a:bodyPr wrap="square">
+            <a:spAutoFit/>
+          </a:bodyPr>
+          <a:lstStyle/>
+          <a:p>
+            <a:pPr algn="l"/>
+            <a:r>
+              <a:rPr sz="1100" b="0" i="0">
                 <a:solidFill>
                   <a:srgbClr val="CCCCCC"/>
                 </a:solidFill>
               </a:rPr>
-              <a:t>A small convolutional denoiser trained to strip adversarial structure from inputs before they reach the detector. It adapts to patch patterns rather than blindly smoothing.</a:t>
+              <a:t>A DPC-UNet denoiser that preprocesses inputs before YOLO inference. In cycle 22, square + c_dog improves mAP50 from 0.363 to 0.394. It is not the strongest defense on every attack.</a:t>
             </a:r>
           </a:p>
         </p:txBody>
@@ -8690,28 +8701,28 @@
         </p:nvSpPr>
         <p:spPr>
           <a:xfrm>
-            <a:off x="6720840" y="3246120"/>
-            <a:ext cx="4480560" cy="228600"/>
-          </a:xfrm>
-          <a:prstGeom prst="rect">
-            <a:avLst/>
-          </a:prstGeom>
-          <a:noFill/>
-        </p:spPr>
-        <p:txBody>
-          <a:bodyPr wrap="square">
-            <a:spAutoFit/>
-          </a:bodyPr>
-          <a:lstStyle/>
-          <a:p>
-            <a:pPr algn="l"/>
-            <a:r>
-              <a:rPr sz="1200" b="0" i="0">
+            <a:off x="6720840" y="3310128"/>
+            <a:ext cx="4480560" cy="274320"/>
+          </a:xfrm>
+          <a:prstGeom prst="rect">
+            <a:avLst/>
+          </a:prstGeom>
+          <a:noFill/>
+        </p:spPr>
+        <p:txBody>
+          <a:bodyPr wrap="square">
+            <a:spAutoFit/>
+          </a:bodyPr>
+          <a:lstStyle/>
+          <a:p>
+            <a:pPr algn="l"/>
+            <a:r>
+              <a:rPr sz="1100" b="0" i="0">
                 <a:solidFill>
                   <a:srgbClr val="FFE066"/>
                 </a:solidFill>
               </a:rPr>
-              <a:t>square + c_dog: mAP50  0.238 -&gt; 0.394   (+65% recovery)</a:t>
+              <a:t>Current snapshot: square attack 0.363 -&gt; square + c_dog 0.394</a:t>
             </a:r>
           </a:p>
         </p:txBody>
@@ -8724,8 +8735,8 @@
         </p:nvSpPr>
         <p:spPr>
           <a:xfrm>
-            <a:off x="6537960" y="3749039"/>
-            <a:ext cx="4800600" cy="1783080"/>
+            <a:off x="6537960" y="3822191"/>
+            <a:ext cx="4800600" cy="1828800"/>
           </a:xfrm>
           <a:prstGeom prst="rect">
             <a:avLst/>
@@ -8802,66 +8813,66 @@
         <p:spPr>
           <a:xfrm>
             <a:off x="6720840" y="4187952"/>
-            <a:ext cx="4480560" cy="1143000"/>
-          </a:xfrm>
-          <a:prstGeom prst="rect">
-            <a:avLst/>
-          </a:prstGeom>
-          <a:noFill/>
-        </p:spPr>
-        <p:txBody>
-          <a:bodyPr wrap="square">
-            <a:spAutoFit/>
-          </a:bodyPr>
-          <a:lstStyle/>
-          <a:p>
-            <a:pPr algn="l"/>
-            <a:r>
-              <a:rPr sz="1100" b="0" i="0">
+            <a:ext cx="4480560" cy="1325880"/>
+          </a:xfrm>
+          <a:prstGeom prst="rect">
+            <a:avLst/>
+          </a:prstGeom>
+          <a:noFill/>
+        </p:spPr>
+        <p:txBody>
+          <a:bodyPr wrap="square">
+            <a:spAutoFit/>
+          </a:bodyPr>
+          <a:lstStyle/>
+          <a:p>
+            <a:pPr algn="l"/>
+            <a:r>
+              <a:rPr sz="1000" b="0" i="0">
                 <a:solidFill>
                   <a:srgbClr val="CCCCCC"/>
                 </a:solidFill>
               </a:rPr>
-              <a:t>- Architecture: DPC-UNet detector</a:t>
-            </a:r>
-          </a:p>
-          <a:p>
-            <a:pPr algn="l"/>
-            <a:r>
-              <a:rPr sz="1100" b="0" i="0">
+              <a:t>- Architecture: DPC-UNet denoiser checkpoint</a:t>
+            </a:r>
+          </a:p>
+          <a:p>
+            <a:pPr algn="l"/>
+            <a:r>
+              <a:rPr sz="1000" b="0" i="0">
                 <a:solidFill>
                   <a:srgbClr val="CCCCCC"/>
                 </a:solidFill>
               </a:rPr>
-              <a:t>- Mix: square x5 oversample + DeepFool + blur pairs</a:t>
-            </a:r>
-          </a:p>
-          <a:p>
-            <a:pPr algn="l"/>
-            <a:r>
-              <a:rPr sz="1100" b="0" i="0">
+              <a:t>- Mix: square x5 oversample + DeepFool + blur + square pairs</a:t>
+            </a:r>
+          </a:p>
+          <a:p>
+            <a:pPr algn="l"/>
+            <a:r>
+              <a:rPr sz="1000" b="0" i="0">
                 <a:solidFill>
                   <a:srgbClr val="CCCCCC"/>
                 </a:solidFill>
               </a:rPr>
-              <a:t>- Gate: deploy only if clean mAP50 &gt;= 0.600</a:t>
-            </a:r>
-          </a:p>
-          <a:p>
-            <a:pPr algn="l"/>
-            <a:r>
-              <a:rPr sz="1100" b="0" i="0">
+              <a:t>- Gate: deploy only if clean A/B does not regress vs current checkpoint</a:t>
+            </a:r>
+          </a:p>
+          <a:p>
+            <a:pPr algn="l"/>
+            <a:r>
+              <a:rPr sz="1000" b="0" i="0">
                 <a:solidFill>
                   <a:srgbClr val="CCCCCC"/>
                 </a:solidFill>
               </a:rPr>
-              <a:t>- Result: +0.003 clean mAP50 - gate passed</a:t>
-            </a:r>
-          </a:p>
-          <a:p>
-            <a:pPr algn="l"/>
-            <a:r>
-              <a:rPr sz="1100" b="0" i="0">
+              <a:t>- Result: +0.0025 clean mAP50 vs previous checkpoint - gate passed</a:t>
+            </a:r>
+          </a:p>
+          <a:p>
+            <a:pPr algn="l"/>
+            <a:r>
+              <a:rPr sz="1000" b="0" i="0">
                 <a:solidFill>
                   <a:srgbClr val="CCCCCC"/>
                 </a:solidFill>
@@ -9258,7 +9269,7 @@
                   <a:srgbClr val="CCCCCC"/>
                 </a:solidFill>
               </a:rPr>
-              <a:t>Physical suppression is roughly 30-60% because printers, lighting, and angle perturb the patch.</a:t>
+              <a:t>Physical demos underperform digital because printer color shift, lighting, and view angle perturb the patch.</a:t>
             </a:r>
           </a:p>
           <a:p>

</xml_diff>